<commit_message>
Publish final audit release, evidence and 90-second demo
Publish the frozen Sites v9 release from source 72e00e9acc2d7fba2e8aea30fb2356ab6df3e3a6. Includes 278 passing tests, 18 source-backed facts, revised materials and new 24-cue demo captions. Update the legacy root SRT alias to the same canonical captions. Source SHA256: 2ba73006675aae03e100cae63918109a99fea64428ef8bfa21080a213b7a558e. Bundle SHA256: 30dd7dba669d9faf44582a1a304524feb46c80b349ecec6d795037528199f725. Metadata will be published separately after verification. The competition form is not submitted.
</commit_message>
<xml_diff>
--- a/qadam-pitch.pptx
+++ b/qadam-pitch.pptx
@@ -2,22 +2,22 @@
 <file path=ppt/presentation.xml><?xml version="1.0" encoding="utf-8"?>
 <p:presentation xmlns:p="http://schemas.openxmlformats.org/presentationml/2006/main">
   <p:sldMasterIdLst>
-    <p:sldMasterId xmlns:r="http://schemas.openxmlformats.org/officeDocument/2006/relationships" id="2147483648" r:id="R78d8de6ebf92458c"/>
+    <p:sldMasterId xmlns:r="http://schemas.openxmlformats.org/officeDocument/2006/relationships" id="2147483648" r:id="Ra913f784cad24c06"/>
   </p:sldMasterIdLst>
   <p:notesMasterIdLst>
-    <p:notesMasterId xmlns:r="http://schemas.openxmlformats.org/officeDocument/2006/relationships" r:id="Ra5adcb59c6a240a2"/>
+    <p:notesMasterId xmlns:r="http://schemas.openxmlformats.org/officeDocument/2006/relationships" r:id="Ra43f23e0a9a74888"/>
   </p:notesMasterIdLst>
   <p:sldIdLst>
-    <p:sldId xmlns:r="http://schemas.openxmlformats.org/officeDocument/2006/relationships" id="256" r:id="R1626284ded994c81"/>
-    <p:sldId xmlns:r="http://schemas.openxmlformats.org/officeDocument/2006/relationships" id="257" r:id="Rb3897558763741a0"/>
-    <p:sldId xmlns:r="http://schemas.openxmlformats.org/officeDocument/2006/relationships" id="258" r:id="Rffeaf879d2164fbb"/>
-    <p:sldId xmlns:r="http://schemas.openxmlformats.org/officeDocument/2006/relationships" id="259" r:id="Rda64f0328d8b44bb"/>
-    <p:sldId xmlns:r="http://schemas.openxmlformats.org/officeDocument/2006/relationships" id="260" r:id="R0eda2c7e900f4f93"/>
-    <p:sldId xmlns:r="http://schemas.openxmlformats.org/officeDocument/2006/relationships" id="261" r:id="Re99ba968261742df"/>
-    <p:sldId xmlns:r="http://schemas.openxmlformats.org/officeDocument/2006/relationships" id="262" r:id="Rd03ddeb117214356"/>
-    <p:sldId xmlns:r="http://schemas.openxmlformats.org/officeDocument/2006/relationships" id="263" r:id="R97978a822f3348cb"/>
-    <p:sldId xmlns:r="http://schemas.openxmlformats.org/officeDocument/2006/relationships" id="264" r:id="Ra8ef1faf52e04ff2"/>
-    <p:sldId xmlns:r="http://schemas.openxmlformats.org/officeDocument/2006/relationships" id="265" r:id="Ra7a338ea3b07405d"/>
+    <p:sldId xmlns:r="http://schemas.openxmlformats.org/officeDocument/2006/relationships" id="256" r:id="R0cc43679edf84f6c"/>
+    <p:sldId xmlns:r="http://schemas.openxmlformats.org/officeDocument/2006/relationships" id="257" r:id="R06bf261f36824863"/>
+    <p:sldId xmlns:r="http://schemas.openxmlformats.org/officeDocument/2006/relationships" id="258" r:id="R7fd782893e5443d3"/>
+    <p:sldId xmlns:r="http://schemas.openxmlformats.org/officeDocument/2006/relationships" id="259" r:id="Ra30eb6a5718f4522"/>
+    <p:sldId xmlns:r="http://schemas.openxmlformats.org/officeDocument/2006/relationships" id="260" r:id="R1ea5088d2bb444ef"/>
+    <p:sldId xmlns:r="http://schemas.openxmlformats.org/officeDocument/2006/relationships" id="261" r:id="R45add31d4e5d45c6"/>
+    <p:sldId xmlns:r="http://schemas.openxmlformats.org/officeDocument/2006/relationships" id="262" r:id="R79b2d1acf8fe4542"/>
+    <p:sldId xmlns:r="http://schemas.openxmlformats.org/officeDocument/2006/relationships" id="263" r:id="R4316fe5b4d3045f9"/>
+    <p:sldId xmlns:r="http://schemas.openxmlformats.org/officeDocument/2006/relationships" id="264" r:id="Re0d8c5ae11cc446c"/>
+    <p:sldId xmlns:r="http://schemas.openxmlformats.org/officeDocument/2006/relationships" id="265" r:id="R1cb2ad44ff334f77"/>
   </p:sldIdLst>
   <p:sldSz cx="12192000" cy="6858000"/>
   <p:notesSz cx="6858000" cy="9144000"/>
@@ -561,7 +561,7 @@
           </a:p>
           <a:p xmlns:a="http://schemas.openxmlformats.org/drawingml/2006/main">
             <a:r>
-              <a:t>https://youtu.be/u8qfP-Jfxq8</a:t>
+              <a:t>https://youtu.be/YsN--AADsZ0</a:t>
             </a:r>
           </a:p>
         </p:txBody>
@@ -816,7 +816,7 @@
           <a:lstStyle xmlns:a="http://schemas.openxmlformats.org/drawingml/2006/main"/>
           <a:p xmlns:a="http://schemas.openxmlformats.org/drawingml/2006/main">
             <a:r>
-              <a:t>Выбираю Парк влюблённых. Официальный городской маршрут рассказывает о скульптуре Ерболата Толепбая «Бақытым менің». Теперь у остановки есть конкретный повод: если скульптура доступна для осмотра, рассмотреть позы фигур и придумать своё название композиции. Это идея наблюдения, её можно пропустить. Сам факт и ссылка на него показаны отдельно. Для первого слоя мы вручную изучили источники о десяти местах, подготовили девятнадцать коротких фактов и четыре наблюдения. Где источника нет, история не появляется из фантазии модели.</a:t>
+              <a:t>Выбираю Парк влюблённых. Официальный городской маршрут рассказывает о скульптуре Ерболата Толепбая «Бақытым менің». Теперь у остановки есть конкретный повод: если скульптура доступна для осмотра, рассмотреть позы фигур и придумать своё название композиции. Это идея наблюдения, её можно пропустить. Сам факт и ссылка на него показаны отдельно. Для первого слоя мы вручную изучили источники о десяти местах, подготовили восемнадцать коротких фактов и четыре наблюдения. Где источника нет, история не появляется из фантазии модели.</a:t>
             </a:r>
           </a:p>
           <a:p xmlns:a="http://schemas.openxmlformats.org/drawingml/2006/main">
@@ -911,7 +911,7 @@
           <a:lstStyle xmlns:a="http://schemas.openxmlformats.org/drawingml/2006/main"/>
           <a:p xmlns:a="http://schemas.openxmlformats.org/drawingml/2006/main">
             <a:r>
-              <a:t>Теперь встречу перенесли раньше. Я сокращаю окно до сорока пяти минут, сохраняя желание и Байтерек. Дальний парк уже не помещается. Qadam предлагает ближний сквер: двадцать две минуты пути, девятнадцать на остановку и четыре на запас. В расчёте возвращаюсь к часу дня. Старый маршрут не остаётся под новыми условиями. Если выполнимого плана нет, приложение объясняет причину и предлагает следующий шаг. Неизвестные свойства места остаются видимыми: исторический факт не подтверждает часы, тишину, цену или розетки.</a:t>
+              <a:t>Теперь встречу перенесли раньше. Я сокращаю окно до сорока пяти минут, сохраняя желание и Байтерек. Дальний парк уже не помещается. Qadam предлагает ближний сквер: двадцать две минуты пути, девятнадцать на остановку и четыре на запас. В расчёте возвращаюсь к часу дня. Точку можно открыть на карте 2ГИС и проверить конкретное место и вход. Старый маршрут не остаётся под новыми условиями. Если выполнимого плана нет, приложение объясняет причину и предлагает следующий шаг. Неизвестные свойства места остаются видимыми: исторический факт не подтверждает часы, тишину, цену или розетки.</a:t>
             </a:r>
           </a:p>
           <a:p xmlns:a="http://schemas.openxmlformats.org/drawingml/2006/main">
@@ -942,6 +942,11 @@
           <a:p xmlns:a="http://schemas.openxmlformats.org/drawingml/2006/main">
             <a:r>
               <a:t>research/vnext-production/06-time-adaptation.png</a:t>
+            </a:r>
+          </a:p>
+          <a:p xmlns:a="http://schemas.openxmlformats.org/drawingml/2006/main">
+            <a:r>
+              <a:t>2GIS destination-only coordinate handoff; entity identity and physical entrance are not guaranteed.</a:t>
             </a:r>
           </a:p>
         </p:txBody>
@@ -1221,7 +1226,7 @@
           <a:lstStyle xmlns:a="http://schemas.openxmlformats.org/drawingml/2006/main"/>
           <a:p xmlns:a="http://schemas.openxmlformats.org/drawingml/2006/main">
             <a:r>
-              <a:t>Каталог собирает наш скрипт через Overpass. В снимке восемьсот девяносто OSM-записей, но расписание есть только у ста шестнадцати. Поэтому небольшой слой с источниками важнее роста счётчика. Двести пятьдесят девять проверок кода проходят без ошибок, в том числе из отдельной чистой установки. Отдельно основной текстовый сценарий с Gemini прошёл в публичном интерфейсе и дал показанные варианты. Это направленная проверка конкретного запроса, не оценка общей точности модели. Полевые входы, переходы и фактическое время ещё предстоит проверить. А пользовательскую пользу нельзя вывести из числа тестов.</a:t>
+              <a:t>Каталог собирает наш скрипт через Overpass. В снимке восемьсот девяносто OSM-записей, но расписание есть только у ста шестнадцати. Поэтому небольшой слой с источниками важнее роста счётчика. Двести семьдесят восемь проверок кода проходят без ошибок. Отдельная чистая установка базовой версии ранее прошла двести пятьдесят девять проверок. Отдельно основной текстовый сценарий с Gemini прошёл в публичном интерфейсе и дал показанные варианты. Это направленная проверка конкретного запроса, не оценка общей точности модели. Полевые входы, переходы и фактическое время ещё предстоит проверить. А пользовательскую пользу нельзя вывести из числа тестов.</a:t>
             </a:r>
           </a:p>
           <a:p xmlns:a="http://schemas.openxmlformats.org/drawingml/2006/main">
@@ -1418,7 +1423,7 @@
           <p:cNvPr id="3" name="Title">
             <a:extLst xmlns:a="http://schemas.openxmlformats.org/drawingml/2006/main">
               <a:ext uri="{FF2B5EF4-FFF2-40B4-BE49-F238E27FC236}">
-                <a16:creationId xmlns:a16="http://schemas.microsoft.com/office/drawing/2014/main" id="{8FDB9C35-5ECB-4DE4-8D72-9A01EB17DE1A}"/>
+                <a16:creationId xmlns:a16="http://schemas.microsoft.com/office/drawing/2014/main" id="{1BB3EFE4-3F30-401F-BC6F-0D422CB85874}"/>
               </a:ext>
             </a:extLst>
           </p:cNvPr>
@@ -1647,7 +1652,7 @@
           <p:cNvPr id="2" name="Subtitle">
             <a:extLst xmlns:a="http://schemas.openxmlformats.org/drawingml/2006/main">
               <a:ext uri="{FF2B5EF4-FFF2-40B4-BE49-F238E27FC236}">
-                <a16:creationId xmlns:a16="http://schemas.microsoft.com/office/drawing/2014/main" id="{1C3DCB34-07E4-4140-AFDA-17FCAE234872}"/>
+                <a16:creationId xmlns:a16="http://schemas.microsoft.com/office/drawing/2014/main" id="{191BC505-9118-431B-BBDC-96B5363AF8D7}"/>
               </a:ext>
             </a:extLst>
           </p:cNvPr>
@@ -1893,7 +1898,7 @@
           <p:cNvPr id="2" name="Section title">
             <a:extLst xmlns:a="http://schemas.openxmlformats.org/drawingml/2006/main">
               <a:ext uri="{FF2B5EF4-FFF2-40B4-BE49-F238E27FC236}">
-                <a16:creationId xmlns:a16="http://schemas.microsoft.com/office/drawing/2014/main" id="{CC96FAD8-7F40-4755-8B46-2A28A23C3701}"/>
+                <a16:creationId xmlns:a16="http://schemas.microsoft.com/office/drawing/2014/main" id="{C817CEC9-2376-4669-92BF-A0CE12EA5D26}"/>
               </a:ext>
             </a:extLst>
           </p:cNvPr>
@@ -2139,7 +2144,7 @@
           <p:cNvPr id="3" name="Title">
             <a:extLst xmlns:a="http://schemas.openxmlformats.org/drawingml/2006/main">
               <a:ext uri="{FF2B5EF4-FFF2-40B4-BE49-F238E27FC236}">
-                <a16:creationId xmlns:a16="http://schemas.microsoft.com/office/drawing/2014/main" id="{CFFE9EA2-309A-4265-9AB5-8DA2924141A8}"/>
+                <a16:creationId xmlns:a16="http://schemas.microsoft.com/office/drawing/2014/main" id="{13F41CC2-BEA9-40F0-8E06-BE9FFDAC7DEF}"/>
               </a:ext>
             </a:extLst>
           </p:cNvPr>
@@ -2368,7 +2373,7 @@
           <p:cNvPr id="2" name="Body">
             <a:extLst xmlns:a="http://schemas.openxmlformats.org/drawingml/2006/main">
               <a:ext uri="{FF2B5EF4-FFF2-40B4-BE49-F238E27FC236}">
-                <a16:creationId xmlns:a16="http://schemas.microsoft.com/office/drawing/2014/main" id="{80EA921F-D881-43CC-819C-DB5337154D4D}"/>
+                <a16:creationId xmlns:a16="http://schemas.microsoft.com/office/drawing/2014/main" id="{0C4C56F1-0CF0-4523-AB5D-0732BCC36702}"/>
               </a:ext>
             </a:extLst>
           </p:cNvPr>
@@ -2614,7 +2619,7 @@
           <p:cNvPr id="4" name="Title">
             <a:extLst xmlns:a="http://schemas.openxmlformats.org/drawingml/2006/main">
               <a:ext uri="{FF2B5EF4-FFF2-40B4-BE49-F238E27FC236}">
-                <a16:creationId xmlns:a16="http://schemas.microsoft.com/office/drawing/2014/main" id="{59D4A669-1A49-4908-A216-09DAA1F84ABD}"/>
+                <a16:creationId xmlns:a16="http://schemas.microsoft.com/office/drawing/2014/main" id="{E8B7E222-D9AF-4B43-BBBD-40570407CA71}"/>
               </a:ext>
             </a:extLst>
           </p:cNvPr>
@@ -2843,7 +2848,7 @@
           <p:cNvPr id="2" name="Left column">
             <a:extLst xmlns:a="http://schemas.openxmlformats.org/drawingml/2006/main">
               <a:ext uri="{FF2B5EF4-FFF2-40B4-BE49-F238E27FC236}">
-                <a16:creationId xmlns:a16="http://schemas.microsoft.com/office/drawing/2014/main" id="{1C4D714D-C80D-4181-83B9-48D93DA233FF}"/>
+                <a16:creationId xmlns:a16="http://schemas.microsoft.com/office/drawing/2014/main" id="{6698AF82-1030-425B-8FA4-094B01BF62F4}"/>
               </a:ext>
             </a:extLst>
           </p:cNvPr>
@@ -3072,7 +3077,7 @@
           <p:cNvPr id="3" name="Right column">
             <a:extLst xmlns:a="http://schemas.openxmlformats.org/drawingml/2006/main">
               <a:ext uri="{FF2B5EF4-FFF2-40B4-BE49-F238E27FC236}">
-                <a16:creationId xmlns:a16="http://schemas.microsoft.com/office/drawing/2014/main" id="{3819BBEE-A3B1-46BD-ADA7-EDFA35C93093}"/>
+                <a16:creationId xmlns:a16="http://schemas.microsoft.com/office/drawing/2014/main" id="{D36C387E-DA14-4B39-A8F4-6E37A81319FD}"/>
               </a:ext>
             </a:extLst>
           </p:cNvPr>
@@ -3318,7 +3323,7 @@
           <p:cNvPr id="3" name="Title">
             <a:extLst xmlns:a="http://schemas.openxmlformats.org/drawingml/2006/main">
               <a:ext uri="{FF2B5EF4-FFF2-40B4-BE49-F238E27FC236}">
-                <a16:creationId xmlns:a16="http://schemas.microsoft.com/office/drawing/2014/main" id="{77F65631-F922-4B9E-8EDB-0A0BF8D7F53E}"/>
+                <a16:creationId xmlns:a16="http://schemas.microsoft.com/office/drawing/2014/main" id="{1FB58715-9072-4BD2-BE83-C38C933DC737}"/>
               </a:ext>
             </a:extLst>
           </p:cNvPr>
@@ -3547,7 +3552,7 @@
           <p:cNvPr id="2" name="Left column">
             <a:extLst xmlns:a="http://schemas.openxmlformats.org/drawingml/2006/main">
               <a:ext uri="{FF2B5EF4-FFF2-40B4-BE49-F238E27FC236}">
-                <a16:creationId xmlns:a16="http://schemas.microsoft.com/office/drawing/2014/main" id="{1EBC08E2-98BD-492B-B2AD-5B649DA4E558}"/>
+                <a16:creationId xmlns:a16="http://schemas.microsoft.com/office/drawing/2014/main" id="{6D6DF2E8-098C-4741-ABE2-607B9EA8C933}"/>
               </a:ext>
             </a:extLst>
           </p:cNvPr>
@@ -3814,12 +3819,12 @@
   </p:cSld>
   <p:clrMap bg1="lt1" tx1="dk1" bg2="lt2" tx2="dk2" accent1="accent1" accent2="accent2" accent3="accent3" accent4="accent4" accent5="accent5" accent6="accent6" hlink="hlink" folHlink="folHlink"/>
   <p:sldLayoutIdLst>
-    <p:sldLayoutId xmlns:r="http://schemas.openxmlformats.org/officeDocument/2006/relationships" id="2147483649" r:id="R50be5230532f455f"/>
-    <p:sldLayoutId xmlns:r="http://schemas.openxmlformats.org/officeDocument/2006/relationships" id="2147483650" r:id="R82d020f812e74861"/>
-    <p:sldLayoutId xmlns:r="http://schemas.openxmlformats.org/officeDocument/2006/relationships" id="2147483651" r:id="R32d05581a63b4c66"/>
-    <p:sldLayoutId xmlns:r="http://schemas.openxmlformats.org/officeDocument/2006/relationships" id="2147483652" r:id="R7d5f59d543384311"/>
-    <p:sldLayoutId xmlns:r="http://schemas.openxmlformats.org/officeDocument/2006/relationships" id="2147483653" r:id="Rc07b92f1a31b4062"/>
-    <p:sldLayoutId xmlns:r="http://schemas.openxmlformats.org/officeDocument/2006/relationships" id="2147483654" r:id="Rf453559ee6324704"/>
+    <p:sldLayoutId xmlns:r="http://schemas.openxmlformats.org/officeDocument/2006/relationships" id="2147483649" r:id="R1163825d9df34af5"/>
+    <p:sldLayoutId xmlns:r="http://schemas.openxmlformats.org/officeDocument/2006/relationships" id="2147483650" r:id="R72f0a7af321940a3"/>
+    <p:sldLayoutId xmlns:r="http://schemas.openxmlformats.org/officeDocument/2006/relationships" id="2147483651" r:id="R178858ccfd844fdc"/>
+    <p:sldLayoutId xmlns:r="http://schemas.openxmlformats.org/officeDocument/2006/relationships" id="2147483652" r:id="Ra812578b71cb4919"/>
+    <p:sldLayoutId xmlns:r="http://schemas.openxmlformats.org/officeDocument/2006/relationships" id="2147483653" r:id="R3b0f3402a0a94845"/>
+    <p:sldLayoutId xmlns:r="http://schemas.openxmlformats.org/officeDocument/2006/relationships" id="2147483654" r:id="R8b3bf266e72f47dd"/>
   </p:sldLayoutIdLst>
   <p:txStyles>
     <p:titleStyle>
@@ -4370,7 +4375,7 @@
           <p:cNvPr id="6" name="">
             <a:extLst xmlns:a="http://schemas.openxmlformats.org/drawingml/2006/main">
               <a:ext uri="{FF2B5EF4-FFF2-40B4-BE49-F238E27FC236}">
-                <a16:creationId xmlns:a16="http://schemas.microsoft.com/office/drawing/2014/main" id="{E2F4B88B-07D2-4045-AB12-2F6A673421B2}"/>
+                <a16:creationId xmlns:a16="http://schemas.microsoft.com/office/drawing/2014/main" id="{F1778440-F31F-48B4-9484-6947AE08774A}"/>
               </a:ext>
             </a:extLst>
           </p:cNvPr>
@@ -4532,7 +4537,7 @@
           <p:cNvPr id="2" name="">
             <a:extLst xmlns:a="http://schemas.openxmlformats.org/drawingml/2006/main">
               <a:ext uri="{FF2B5EF4-FFF2-40B4-BE49-F238E27FC236}">
-                <a16:creationId xmlns:a16="http://schemas.microsoft.com/office/drawing/2014/main" id="{A6B57887-A976-44BD-8C10-DFB2CBF23FF5}"/>
+                <a16:creationId xmlns:a16="http://schemas.microsoft.com/office/drawing/2014/main" id="{2C6C8B62-D278-43EA-9576-2AB12645A569}"/>
               </a:ext>
             </a:extLst>
           </p:cNvPr>
@@ -4694,7 +4699,7 @@
           <p:cNvPr id="3" name="">
             <a:extLst xmlns:a="http://schemas.openxmlformats.org/drawingml/2006/main">
               <a:ext uri="{FF2B5EF4-FFF2-40B4-BE49-F238E27FC236}">
-                <a16:creationId xmlns:a16="http://schemas.microsoft.com/office/drawing/2014/main" id="{ADD4E9F0-05CF-4857-8AB6-F1CB879C2AA9}"/>
+                <a16:creationId xmlns:a16="http://schemas.microsoft.com/office/drawing/2014/main" id="{180DD1AB-4A3C-4BC9-AC1A-EEC061B6EA05}"/>
               </a:ext>
             </a:extLst>
           </p:cNvPr>
@@ -4856,7 +4861,7 @@
           <p:cNvPr id="4" name="">
             <a:extLst xmlns:a="http://schemas.openxmlformats.org/drawingml/2006/main">
               <a:ext uri="{FF2B5EF4-FFF2-40B4-BE49-F238E27FC236}">
-                <a16:creationId xmlns:a16="http://schemas.microsoft.com/office/drawing/2014/main" id="{190DB0A5-D5FE-4308-9433-EC84A366C9B1}"/>
+                <a16:creationId xmlns:a16="http://schemas.microsoft.com/office/drawing/2014/main" id="{C4BE6F11-0CEA-4F0D-BE9A-F5BFA928F3EC}"/>
               </a:ext>
             </a:extLst>
           </p:cNvPr>
@@ -5018,7 +5023,7 @@
           <p:cNvPr id="5" name="">
             <a:extLst xmlns:a="http://schemas.openxmlformats.org/drawingml/2006/main">
               <a:ext uri="{FF2B5EF4-FFF2-40B4-BE49-F238E27FC236}">
-                <a16:creationId xmlns:a16="http://schemas.microsoft.com/office/drawing/2014/main" id="{A48028AC-2A17-4B4F-8FDF-3C8386BC6FC4}"/>
+                <a16:creationId xmlns:a16="http://schemas.microsoft.com/office/drawing/2014/main" id="{28DA7071-047C-4DD9-A5BE-0E1B98FCC515}"/>
               </a:ext>
             </a:extLst>
           </p:cNvPr>
@@ -5178,7 +5183,7 @@
     </p:spTree>
     <p:extLst>
       <p:ext uri="{BB962C8B-B14F-4D97-AF65-F5344CB8AC3E}">
-        <p14:creationId xmlns:p14="http://schemas.microsoft.com/office/powerpoint/2010/main" val="842806213"/>
+        <p14:creationId xmlns:p14="http://schemas.microsoft.com/office/powerpoint/2010/main" val="2132305302"/>
       </p:ext>
     </p:extLst>
   </p:cSld>
@@ -5209,7 +5214,7 @@
           <p:cNvPr id="12" name="">
             <a:extLst xmlns:a="http://schemas.openxmlformats.org/drawingml/2006/main">
               <a:ext uri="{FF2B5EF4-FFF2-40B4-BE49-F238E27FC236}">
-                <a16:creationId xmlns:a16="http://schemas.microsoft.com/office/drawing/2014/main" id="{90826EDC-77D9-4E62-84C6-40F4EAE15C4D}"/>
+                <a16:creationId xmlns:a16="http://schemas.microsoft.com/office/drawing/2014/main" id="{C6BBC37C-C72C-443B-8827-CC52FCEE17FF}"/>
               </a:ext>
             </a:extLst>
           </p:cNvPr>
@@ -5371,7 +5376,7 @@
           <p:cNvPr id="2" name="">
             <a:extLst xmlns:a="http://schemas.openxmlformats.org/drawingml/2006/main">
               <a:ext uri="{FF2B5EF4-FFF2-40B4-BE49-F238E27FC236}">
-                <a16:creationId xmlns:a16="http://schemas.microsoft.com/office/drawing/2014/main" id="{202C1951-FB5D-4850-8FAE-A9FBBCD836FA}"/>
+                <a16:creationId xmlns:a16="http://schemas.microsoft.com/office/drawing/2014/main" id="{414B4E0B-DDA0-42E8-865E-18B9ED5FAF98}"/>
               </a:ext>
             </a:extLst>
           </p:cNvPr>
@@ -5560,7 +5565,7 @@
           <p:cNvPr id="3" name="">
             <a:extLst xmlns:a="http://schemas.openxmlformats.org/drawingml/2006/main">
               <a:ext uri="{FF2B5EF4-FFF2-40B4-BE49-F238E27FC236}">
-                <a16:creationId xmlns:a16="http://schemas.microsoft.com/office/drawing/2014/main" id="{213BF67C-9501-4D81-A259-14D0F295C41A}"/>
+                <a16:creationId xmlns:a16="http://schemas.microsoft.com/office/drawing/2014/main" id="{7A59D155-9205-4610-B5F1-9CB7D6F50B66}"/>
               </a:ext>
             </a:extLst>
           </p:cNvPr>
@@ -5722,7 +5727,7 @@
           <p:cNvPr id="4" name="">
             <a:extLst xmlns:a="http://schemas.openxmlformats.org/drawingml/2006/main">
               <a:ext uri="{FF2B5EF4-FFF2-40B4-BE49-F238E27FC236}">
-                <a16:creationId xmlns:a16="http://schemas.microsoft.com/office/drawing/2014/main" id="{F530E1CC-AC7B-4016-8668-3C0165FA454B}"/>
+                <a16:creationId xmlns:a16="http://schemas.microsoft.com/office/drawing/2014/main" id="{F0D334F8-EB63-46E0-8277-5312FA272239}"/>
               </a:ext>
             </a:extLst>
           </p:cNvPr>
@@ -5873,7 +5878,7 @@
                 <a:latin typeface="Arial"/>
                 <a:ea typeface="Arial"/>
                 <a:cs typeface="Arial"/>
-                <a:hlinkClick xmlns:r="http://schemas.openxmlformats.org/officeDocument/2006/relationships" r:id="Rce35bde2d7a044b8"/>
+                <a:hlinkClick xmlns:r="http://schemas.openxmlformats.org/officeDocument/2006/relationships" r:id="R04727f7face04a04"/>
               </a:rPr>
               <a:t>qadam-astana-walk.pubg-bekzat.chatgpt.site/</a:t>
             </a:r>
@@ -5885,7 +5890,7 @@
           <p:cNvPr id="5" name="">
             <a:extLst xmlns:a="http://schemas.openxmlformats.org/drawingml/2006/main">
               <a:ext uri="{FF2B5EF4-FFF2-40B4-BE49-F238E27FC236}">
-                <a16:creationId xmlns:a16="http://schemas.microsoft.com/office/drawing/2014/main" id="{9037DE5C-7A90-4ADD-9120-C63C983AD6BE}"/>
+                <a16:creationId xmlns:a16="http://schemas.microsoft.com/office/drawing/2014/main" id="{237A448D-D89A-480F-B412-5FF4B5181BEA}"/>
               </a:ext>
             </a:extLst>
           </p:cNvPr>
@@ -6047,7 +6052,7 @@
           <p:cNvPr id="6" name="">
             <a:extLst xmlns:a="http://schemas.openxmlformats.org/drawingml/2006/main">
               <a:ext uri="{FF2B5EF4-FFF2-40B4-BE49-F238E27FC236}">
-                <a16:creationId xmlns:a16="http://schemas.microsoft.com/office/drawing/2014/main" id="{24062CFA-2D1E-4FA3-B62F-C8484D35E7A4}"/>
+                <a16:creationId xmlns:a16="http://schemas.microsoft.com/office/drawing/2014/main" id="{AD76AAB7-4625-46DC-8E54-30156DE14EDF}"/>
               </a:ext>
             </a:extLst>
           </p:cNvPr>
@@ -6198,7 +6203,7 @@
                 <a:latin typeface="Arial"/>
                 <a:ea typeface="Arial"/>
                 <a:cs typeface="Arial"/>
-                <a:hlinkClick xmlns:r="http://schemas.openxmlformats.org/officeDocument/2006/relationships" r:id="R3dc188c575d7429b"/>
+                <a:hlinkClick xmlns:r="http://schemas.openxmlformats.org/officeDocument/2006/relationships" r:id="R5e291713c5854051"/>
               </a:rPr>
               <a:t>github.com/gojosatorukz/qadam-astana</a:t>
             </a:r>
@@ -6210,7 +6215,7 @@
           <p:cNvPr id="7" name="">
             <a:extLst xmlns:a="http://schemas.openxmlformats.org/drawingml/2006/main">
               <a:ext uri="{FF2B5EF4-FFF2-40B4-BE49-F238E27FC236}">
-                <a16:creationId xmlns:a16="http://schemas.microsoft.com/office/drawing/2014/main" id="{F112B895-6FB6-4CB1-9082-10CDD4FA478B}"/>
+                <a16:creationId xmlns:a16="http://schemas.microsoft.com/office/drawing/2014/main" id="{6332583C-3243-4707-8D56-F5212281AEE3}"/>
               </a:ext>
             </a:extLst>
           </p:cNvPr>
@@ -6372,7 +6377,7 @@
           <p:cNvPr id="8" name="">
             <a:extLst xmlns:a="http://schemas.openxmlformats.org/drawingml/2006/main">
               <a:ext uri="{FF2B5EF4-FFF2-40B4-BE49-F238E27FC236}">
-                <a16:creationId xmlns:a16="http://schemas.microsoft.com/office/drawing/2014/main" id="{13A41127-E72B-4597-8A96-6C2C6C3968A5}"/>
+                <a16:creationId xmlns:a16="http://schemas.microsoft.com/office/drawing/2014/main" id="{0665FE89-C72B-4705-91EC-18EA44AE46E6}"/>
               </a:ext>
             </a:extLst>
           </p:cNvPr>
@@ -6523,9 +6528,9 @@
                 <a:latin typeface="Arial"/>
                 <a:ea typeface="Arial"/>
                 <a:cs typeface="Arial"/>
-                <a:hlinkClick xmlns:r="http://schemas.openxmlformats.org/officeDocument/2006/relationships" r:id="R01e829ac013c4d68"/>
+                <a:hlinkClick xmlns:r="http://schemas.openxmlformats.org/officeDocument/2006/relationships" r:id="Rc2d47cc8040b4c07"/>
               </a:rPr>
-              <a:t>youtu.be/u8qfP-Jfxq8</a:t>
+              <a:t>youtu.be/YsN--AADsZ0</a:t>
             </a:r>
           </a:p>
         </p:txBody>
@@ -6535,7 +6540,7 @@
           <p:cNvPr id="9" name="">
             <a:extLst xmlns:a="http://schemas.openxmlformats.org/drawingml/2006/main">
               <a:ext uri="{FF2B5EF4-FFF2-40B4-BE49-F238E27FC236}">
-                <a16:creationId xmlns:a16="http://schemas.microsoft.com/office/drawing/2014/main" id="{FEE036E2-521A-4C26-ACE7-F51791579E3B}"/>
+                <a16:creationId xmlns:a16="http://schemas.microsoft.com/office/drawing/2014/main" id="{02579BD3-9802-4172-9B16-8675C8A2E9C7}"/>
               </a:ext>
             </a:extLst>
           </p:cNvPr>
@@ -6545,7 +6550,7 @@
           <p:nvPr/>
         </p:nvPicPr>
         <p:blipFill>
-          <a:blip xmlns:r="http://schemas.openxmlformats.org/officeDocument/2006/relationships" xmlns:a="http://schemas.openxmlformats.org/drawingml/2006/main" r:embed="Rb9271f048212498d"/>
+          <a:blip xmlns:r="http://schemas.openxmlformats.org/officeDocument/2006/relationships" xmlns:a="http://schemas.openxmlformats.org/drawingml/2006/main" r:embed="R6be72be13e6842d4"/>
           <a:stretch xmlns:a="http://schemas.openxmlformats.org/drawingml/2006/main"/>
         </p:blipFill>
         <p:spPr>
@@ -6563,7 +6568,7 @@
           <p:cNvPr id="10" name="">
             <a:extLst xmlns:a="http://schemas.openxmlformats.org/drawingml/2006/main">
               <a:ext uri="{FF2B5EF4-FFF2-40B4-BE49-F238E27FC236}">
-                <a16:creationId xmlns:a16="http://schemas.microsoft.com/office/drawing/2014/main" id="{2A7F7DFB-A06B-4006-AA72-45CF7C51AF5A}"/>
+                <a16:creationId xmlns:a16="http://schemas.microsoft.com/office/drawing/2014/main" id="{657199FC-34D0-451A-BF71-58DFAA94F2E9}"/>
               </a:ext>
             </a:extLst>
           </p:cNvPr>
@@ -6725,7 +6730,7 @@
           <p:cNvPr id="11" name="">
             <a:extLst xmlns:a="http://schemas.openxmlformats.org/drawingml/2006/main">
               <a:ext uri="{FF2B5EF4-FFF2-40B4-BE49-F238E27FC236}">
-                <a16:creationId xmlns:a16="http://schemas.microsoft.com/office/drawing/2014/main" id="{8FC07FFC-3F78-4618-9599-3D9CD65F05F0}"/>
+                <a16:creationId xmlns:a16="http://schemas.microsoft.com/office/drawing/2014/main" id="{99303E16-480E-49BF-A780-A385FABA8AF8}"/>
               </a:ext>
             </a:extLst>
           </p:cNvPr>
@@ -6885,7 +6890,7 @@
     </p:spTree>
     <p:extLst>
       <p:ext uri="{BB962C8B-B14F-4D97-AF65-F5344CB8AC3E}">
-        <p14:creationId xmlns:p14="http://schemas.microsoft.com/office/powerpoint/2010/main" val="1057692716"/>
+        <p14:creationId xmlns:p14="http://schemas.microsoft.com/office/powerpoint/2010/main" val="536272392"/>
       </p:ext>
     </p:extLst>
   </p:cSld>
@@ -6916,7 +6921,7 @@
           <p:cNvPr id="9" name="">
             <a:extLst xmlns:a="http://schemas.openxmlformats.org/drawingml/2006/main">
               <a:ext uri="{FF2B5EF4-FFF2-40B4-BE49-F238E27FC236}">
-                <a16:creationId xmlns:a16="http://schemas.microsoft.com/office/drawing/2014/main" id="{60714B54-FB8A-4C23-9104-8C3719DFD5BD}"/>
+                <a16:creationId xmlns:a16="http://schemas.microsoft.com/office/drawing/2014/main" id="{BCD83552-F3BE-413D-A259-D29FD689651F}"/>
               </a:ext>
             </a:extLst>
           </p:cNvPr>
@@ -7078,7 +7083,7 @@
           <p:cNvPr id="2" name="">
             <a:extLst xmlns:a="http://schemas.openxmlformats.org/drawingml/2006/main">
               <a:ext uri="{FF2B5EF4-FFF2-40B4-BE49-F238E27FC236}">
-                <a16:creationId xmlns:a16="http://schemas.microsoft.com/office/drawing/2014/main" id="{2A619789-7186-496A-97B4-619D6DD52B7B}"/>
+                <a16:creationId xmlns:a16="http://schemas.microsoft.com/office/drawing/2014/main" id="{B3334459-F8E8-4850-AE8B-B34273FED9E4}"/>
               </a:ext>
             </a:extLst>
           </p:cNvPr>
@@ -7088,7 +7093,7 @@
           <p:nvPr/>
         </p:nvPicPr>
         <p:blipFill>
-          <a:blip xmlns:r="http://schemas.openxmlformats.org/officeDocument/2006/relationships" xmlns:a="http://schemas.openxmlformats.org/drawingml/2006/main" r:embed="R74c0743495ca46e0"/>
+          <a:blip xmlns:r="http://schemas.openxmlformats.org/officeDocument/2006/relationships" xmlns:a="http://schemas.openxmlformats.org/drawingml/2006/main" r:embed="R4d4e18f8699f4335"/>
           <a:srcRect xmlns:a="http://schemas.openxmlformats.org/drawingml/2006/main" l="5000" t="44444" r="45313" b="6944"/>
           <a:stretch xmlns:a="http://schemas.openxmlformats.org/drawingml/2006/main"/>
         </p:blipFill>
@@ -7107,7 +7112,7 @@
           <p:cNvPr id="3" name="">
             <a:extLst xmlns:a="http://schemas.openxmlformats.org/drawingml/2006/main">
               <a:ext uri="{FF2B5EF4-FFF2-40B4-BE49-F238E27FC236}">
-                <a16:creationId xmlns:a16="http://schemas.microsoft.com/office/drawing/2014/main" id="{972FCA94-9873-4A29-A095-AD50BF0CE44E}"/>
+                <a16:creationId xmlns:a16="http://schemas.microsoft.com/office/drawing/2014/main" id="{5D3C0136-9EBE-4437-A08F-66D38ED4C4EF}"/>
               </a:ext>
             </a:extLst>
           </p:cNvPr>
@@ -7296,7 +7301,7 @@
           <p:cNvPr id="4" name="">
             <a:extLst xmlns:a="http://schemas.openxmlformats.org/drawingml/2006/main">
               <a:ext uri="{FF2B5EF4-FFF2-40B4-BE49-F238E27FC236}">
-                <a16:creationId xmlns:a16="http://schemas.microsoft.com/office/drawing/2014/main" id="{2276FD6C-833B-4E87-802F-ACF602B6C147}"/>
+                <a16:creationId xmlns:a16="http://schemas.microsoft.com/office/drawing/2014/main" id="{B8D1D845-3C30-4B1C-A005-33FF46EBAD68}"/>
               </a:ext>
             </a:extLst>
           </p:cNvPr>
@@ -7458,7 +7463,7 @@
           <p:cNvPr id="5" name="">
             <a:extLst xmlns:a="http://schemas.openxmlformats.org/drawingml/2006/main">
               <a:ext uri="{FF2B5EF4-FFF2-40B4-BE49-F238E27FC236}">
-                <a16:creationId xmlns:a16="http://schemas.microsoft.com/office/drawing/2014/main" id="{41D382D7-B664-4FDF-BBAC-10DD90A5EA75}"/>
+                <a16:creationId xmlns:a16="http://schemas.microsoft.com/office/drawing/2014/main" id="{E78A1184-D60A-4CB9-B183-FE3E400E599C}"/>
               </a:ext>
             </a:extLst>
           </p:cNvPr>
@@ -7620,7 +7625,7 @@
           <p:cNvPr id="6" name="">
             <a:extLst xmlns:a="http://schemas.openxmlformats.org/drawingml/2006/main">
               <a:ext uri="{FF2B5EF4-FFF2-40B4-BE49-F238E27FC236}">
-                <a16:creationId xmlns:a16="http://schemas.microsoft.com/office/drawing/2014/main" id="{35D860F0-63A2-45B0-82B8-CC8781C5B9AA}"/>
+                <a16:creationId xmlns:a16="http://schemas.microsoft.com/office/drawing/2014/main" id="{5712AA41-11B7-4EC0-BF40-B37ABF9253C0}"/>
               </a:ext>
             </a:extLst>
           </p:cNvPr>
@@ -7782,7 +7787,7 @@
           <p:cNvPr id="7" name="">
             <a:extLst xmlns:a="http://schemas.openxmlformats.org/drawingml/2006/main">
               <a:ext uri="{FF2B5EF4-FFF2-40B4-BE49-F238E27FC236}">
-                <a16:creationId xmlns:a16="http://schemas.microsoft.com/office/drawing/2014/main" id="{7D2243D6-7B30-42CF-9A45-F5F2815ADD24}"/>
+                <a16:creationId xmlns:a16="http://schemas.microsoft.com/office/drawing/2014/main" id="{2605F361-715B-4C97-9DA9-9B764D5860C5}"/>
               </a:ext>
             </a:extLst>
           </p:cNvPr>
@@ -7944,7 +7949,7 @@
           <p:cNvPr id="8" name="">
             <a:extLst xmlns:a="http://schemas.openxmlformats.org/drawingml/2006/main">
               <a:ext uri="{FF2B5EF4-FFF2-40B4-BE49-F238E27FC236}">
-                <a16:creationId xmlns:a16="http://schemas.microsoft.com/office/drawing/2014/main" id="{5F78EECF-0ACC-4CE7-BC54-2C80385CBF23}"/>
+                <a16:creationId xmlns:a16="http://schemas.microsoft.com/office/drawing/2014/main" id="{4E87C41E-8F89-4064-92D1-6E02C1A2987B}"/>
               </a:ext>
             </a:extLst>
           </p:cNvPr>
@@ -8104,7 +8109,7 @@
     </p:spTree>
     <p:extLst>
       <p:ext uri="{BB962C8B-B14F-4D97-AF65-F5344CB8AC3E}">
-        <p14:creationId xmlns:p14="http://schemas.microsoft.com/office/powerpoint/2010/main" val="1764941788"/>
+        <p14:creationId xmlns:p14="http://schemas.microsoft.com/office/powerpoint/2010/main" val="938920395"/>
       </p:ext>
     </p:extLst>
   </p:cSld>
@@ -8135,7 +8140,7 @@
           <p:cNvPr id="8" name="">
             <a:extLst xmlns:a="http://schemas.openxmlformats.org/drawingml/2006/main">
               <a:ext uri="{FF2B5EF4-FFF2-40B4-BE49-F238E27FC236}">
-                <a16:creationId xmlns:a16="http://schemas.microsoft.com/office/drawing/2014/main" id="{3E9F6701-94D0-480F-B3DC-C07FC13D9ABF}"/>
+                <a16:creationId xmlns:a16="http://schemas.microsoft.com/office/drawing/2014/main" id="{A1042568-1895-4728-8F15-7B6EF2AFE7F6}"/>
               </a:ext>
             </a:extLst>
           </p:cNvPr>
@@ -8297,7 +8302,7 @@
           <p:cNvPr id="2" name="">
             <a:extLst xmlns:a="http://schemas.openxmlformats.org/drawingml/2006/main">
               <a:ext uri="{FF2B5EF4-FFF2-40B4-BE49-F238E27FC236}">
-                <a16:creationId xmlns:a16="http://schemas.microsoft.com/office/drawing/2014/main" id="{7D250288-47A7-4AA3-B465-8786D8852F4A}"/>
+                <a16:creationId xmlns:a16="http://schemas.microsoft.com/office/drawing/2014/main" id="{345BCF63-EC6B-4106-AC4B-3903C78AC551}"/>
               </a:ext>
             </a:extLst>
           </p:cNvPr>
@@ -8307,7 +8312,7 @@
           <p:nvPr/>
         </p:nvPicPr>
         <p:blipFill>
-          <a:blip xmlns:r="http://schemas.openxmlformats.org/officeDocument/2006/relationships" xmlns:a="http://schemas.openxmlformats.org/drawingml/2006/main" r:embed="Rd5657b30327042d8"/>
+          <a:blip xmlns:r="http://schemas.openxmlformats.org/officeDocument/2006/relationships" xmlns:a="http://schemas.openxmlformats.org/drawingml/2006/main" r:embed="Rb66d05f95cf64117"/>
           <a:srcRect xmlns:a="http://schemas.openxmlformats.org/drawingml/2006/main" l="5000" t="31250" r="51719" b="26250"/>
           <a:stretch xmlns:a="http://schemas.openxmlformats.org/drawingml/2006/main"/>
         </p:blipFill>
@@ -8326,7 +8331,7 @@
           <p:cNvPr id="3" name="">
             <a:extLst xmlns:a="http://schemas.openxmlformats.org/drawingml/2006/main">
               <a:ext uri="{FF2B5EF4-FFF2-40B4-BE49-F238E27FC236}">
-                <a16:creationId xmlns:a16="http://schemas.microsoft.com/office/drawing/2014/main" id="{44C6C890-EF3B-4101-9E4C-1E49E9EBAFA0}"/>
+                <a16:creationId xmlns:a16="http://schemas.microsoft.com/office/drawing/2014/main" id="{EA641CB2-0FB4-4E24-8B33-2EA9DD54C266}"/>
               </a:ext>
             </a:extLst>
           </p:cNvPr>
@@ -8488,7 +8493,7 @@
           <p:cNvPr id="4" name="">
             <a:extLst xmlns:a="http://schemas.openxmlformats.org/drawingml/2006/main">
               <a:ext uri="{FF2B5EF4-FFF2-40B4-BE49-F238E27FC236}">
-                <a16:creationId xmlns:a16="http://schemas.microsoft.com/office/drawing/2014/main" id="{17476BB6-B69C-4541-B953-846420BCE1A4}"/>
+                <a16:creationId xmlns:a16="http://schemas.microsoft.com/office/drawing/2014/main" id="{86CDD7A1-95D8-4C60-A295-7D231A628AE1}"/>
               </a:ext>
             </a:extLst>
           </p:cNvPr>
@@ -8650,7 +8655,7 @@
           <p:cNvPr id="5" name="">
             <a:extLst xmlns:a="http://schemas.openxmlformats.org/drawingml/2006/main">
               <a:ext uri="{FF2B5EF4-FFF2-40B4-BE49-F238E27FC236}">
-                <a16:creationId xmlns:a16="http://schemas.microsoft.com/office/drawing/2014/main" id="{44095223-8759-4A06-86DA-45FED94D4439}"/>
+                <a16:creationId xmlns:a16="http://schemas.microsoft.com/office/drawing/2014/main" id="{BD538D30-5C9C-406F-B147-752F51C5B3AE}"/>
               </a:ext>
             </a:extLst>
           </p:cNvPr>
@@ -8812,7 +8817,7 @@
           <p:cNvPr id="6" name="">
             <a:extLst xmlns:a="http://schemas.openxmlformats.org/drawingml/2006/main">
               <a:ext uri="{FF2B5EF4-FFF2-40B4-BE49-F238E27FC236}">
-                <a16:creationId xmlns:a16="http://schemas.microsoft.com/office/drawing/2014/main" id="{E1245469-16B9-4792-93E8-ACAA2D1966E3}"/>
+                <a16:creationId xmlns:a16="http://schemas.microsoft.com/office/drawing/2014/main" id="{FFA1257D-3889-42AC-9C05-28C44197CE56}"/>
               </a:ext>
             </a:extLst>
           </p:cNvPr>
@@ -8974,7 +8979,7 @@
           <p:cNvPr id="7" name="">
             <a:extLst xmlns:a="http://schemas.openxmlformats.org/drawingml/2006/main">
               <a:ext uri="{FF2B5EF4-FFF2-40B4-BE49-F238E27FC236}">
-                <a16:creationId xmlns:a16="http://schemas.microsoft.com/office/drawing/2014/main" id="{A911DEE1-E041-4D5E-A807-83845C639FFC}"/>
+                <a16:creationId xmlns:a16="http://schemas.microsoft.com/office/drawing/2014/main" id="{DD536E33-D3B1-41C7-B8BF-F8A920C3A13C}"/>
               </a:ext>
             </a:extLst>
           </p:cNvPr>
@@ -9134,7 +9139,7 @@
     </p:spTree>
     <p:extLst>
       <p:ext uri="{BB962C8B-B14F-4D97-AF65-F5344CB8AC3E}">
-        <p14:creationId xmlns:p14="http://schemas.microsoft.com/office/powerpoint/2010/main" val="1428685851"/>
+        <p14:creationId xmlns:p14="http://schemas.microsoft.com/office/powerpoint/2010/main" val="1166667802"/>
       </p:ext>
     </p:extLst>
   </p:cSld>
@@ -9165,7 +9170,7 @@
           <p:cNvPr id="8" name="">
             <a:extLst xmlns:a="http://schemas.openxmlformats.org/drawingml/2006/main">
               <a:ext uri="{FF2B5EF4-FFF2-40B4-BE49-F238E27FC236}">
-                <a16:creationId xmlns:a16="http://schemas.microsoft.com/office/drawing/2014/main" id="{AA582A4B-C0FC-4DD3-9EDD-A84CDFA52B94}"/>
+                <a16:creationId xmlns:a16="http://schemas.microsoft.com/office/drawing/2014/main" id="{6E5AE217-5F33-46F4-8CD0-648DD14FC963}"/>
               </a:ext>
             </a:extLst>
           </p:cNvPr>
@@ -9327,7 +9332,7 @@
           <p:cNvPr id="2" name="">
             <a:extLst xmlns:a="http://schemas.openxmlformats.org/drawingml/2006/main">
               <a:ext uri="{FF2B5EF4-FFF2-40B4-BE49-F238E27FC236}">
-                <a16:creationId xmlns:a16="http://schemas.microsoft.com/office/drawing/2014/main" id="{C7F49176-A7A6-4ACE-BADC-21B0E9717222}"/>
+                <a16:creationId xmlns:a16="http://schemas.microsoft.com/office/drawing/2014/main" id="{A53E9426-03F6-408F-9E0C-BDC43D81B18C}"/>
               </a:ext>
             </a:extLst>
           </p:cNvPr>
@@ -9337,7 +9342,7 @@
           <p:nvPr/>
         </p:nvPicPr>
         <p:blipFill>
-          <a:blip xmlns:r="http://schemas.openxmlformats.org/officeDocument/2006/relationships" xmlns:a="http://schemas.openxmlformats.org/drawingml/2006/main" r:embed="R199b3f101a1042e4"/>
+          <a:blip xmlns:r="http://schemas.openxmlformats.org/officeDocument/2006/relationships" xmlns:a="http://schemas.openxmlformats.org/drawingml/2006/main" r:embed="Re237c03ba0b64a78"/>
           <a:srcRect xmlns:a="http://schemas.openxmlformats.org/drawingml/2006/main" l="5000" t="41111" r="51719" b="3333"/>
           <a:stretch xmlns:a="http://schemas.openxmlformats.org/drawingml/2006/main"/>
         </p:blipFill>
@@ -9356,7 +9361,7 @@
           <p:cNvPr id="3" name="">
             <a:extLst xmlns:a="http://schemas.openxmlformats.org/drawingml/2006/main">
               <a:ext uri="{FF2B5EF4-FFF2-40B4-BE49-F238E27FC236}">
-                <a16:creationId xmlns:a16="http://schemas.microsoft.com/office/drawing/2014/main" id="{E757498E-EBA0-43D6-83FE-C096A28D9EE2}"/>
+                <a16:creationId xmlns:a16="http://schemas.microsoft.com/office/drawing/2014/main" id="{C986C024-7D23-4D7D-9B23-E1EECC18E079}"/>
               </a:ext>
             </a:extLst>
           </p:cNvPr>
@@ -9518,7 +9523,7 @@
           <p:cNvPr id="4" name="">
             <a:extLst xmlns:a="http://schemas.openxmlformats.org/drawingml/2006/main">
               <a:ext uri="{FF2B5EF4-FFF2-40B4-BE49-F238E27FC236}">
-                <a16:creationId xmlns:a16="http://schemas.microsoft.com/office/drawing/2014/main" id="{D54774A7-CD80-49CD-A14E-06C2027DFB04}"/>
+                <a16:creationId xmlns:a16="http://schemas.microsoft.com/office/drawing/2014/main" id="{4522E1ED-5005-41FB-BE66-83CEC7256C5F}"/>
               </a:ext>
             </a:extLst>
           </p:cNvPr>
@@ -9680,7 +9685,7 @@
           <p:cNvPr id="5" name="">
             <a:extLst xmlns:a="http://schemas.openxmlformats.org/drawingml/2006/main">
               <a:ext uri="{FF2B5EF4-FFF2-40B4-BE49-F238E27FC236}">
-                <a16:creationId xmlns:a16="http://schemas.microsoft.com/office/drawing/2014/main" id="{EBA3225F-0345-49DC-8FF8-1E1B7239BFE4}"/>
+                <a16:creationId xmlns:a16="http://schemas.microsoft.com/office/drawing/2014/main" id="{D9D243DF-C56A-4595-B109-02D572D024D3}"/>
               </a:ext>
             </a:extLst>
           </p:cNvPr>
@@ -9832,7 +9837,7 @@
                 <a:ea typeface="Georgia"/>
                 <a:cs typeface="Georgia"/>
               </a:rPr>
-              <a:t>19</a:t>
+              <a:t>18</a:t>
             </a:r>
           </a:p>
         </p:txBody>
@@ -9842,7 +9847,7 @@
           <p:cNvPr id="6" name="">
             <a:extLst xmlns:a="http://schemas.openxmlformats.org/drawingml/2006/main">
               <a:ext uri="{FF2B5EF4-FFF2-40B4-BE49-F238E27FC236}">
-                <a16:creationId xmlns:a16="http://schemas.microsoft.com/office/drawing/2014/main" id="{D52A9A1B-5141-4747-BFAF-9E5FB7E949AC}"/>
+                <a16:creationId xmlns:a16="http://schemas.microsoft.com/office/drawing/2014/main" id="{CC7B9CF8-8A04-44E9-B41D-1EA49E2801C1}"/>
               </a:ext>
             </a:extLst>
           </p:cNvPr>
@@ -10004,7 +10009,7 @@
           <p:cNvPr id="7" name="">
             <a:extLst xmlns:a="http://schemas.openxmlformats.org/drawingml/2006/main">
               <a:ext uri="{FF2B5EF4-FFF2-40B4-BE49-F238E27FC236}">
-                <a16:creationId xmlns:a16="http://schemas.microsoft.com/office/drawing/2014/main" id="{7C4FFB24-80D7-4230-AEB1-FDD44213BE63}"/>
+                <a16:creationId xmlns:a16="http://schemas.microsoft.com/office/drawing/2014/main" id="{016CB570-EED5-4C1C-9215-FAEC74BA489A}"/>
               </a:ext>
             </a:extLst>
           </p:cNvPr>
@@ -10164,7 +10169,7 @@
     </p:spTree>
     <p:extLst>
       <p:ext uri="{BB962C8B-B14F-4D97-AF65-F5344CB8AC3E}">
-        <p14:creationId xmlns:p14="http://schemas.microsoft.com/office/powerpoint/2010/main" val="111945845"/>
+        <p14:creationId xmlns:p14="http://schemas.microsoft.com/office/powerpoint/2010/main" val="1247879791"/>
       </p:ext>
     </p:extLst>
   </p:cSld>
@@ -10195,7 +10200,7 @@
           <p:cNvPr id="6" name="">
             <a:extLst xmlns:a="http://schemas.openxmlformats.org/drawingml/2006/main">
               <a:ext uri="{FF2B5EF4-FFF2-40B4-BE49-F238E27FC236}">
-                <a16:creationId xmlns:a16="http://schemas.microsoft.com/office/drawing/2014/main" id="{E30BF54C-CD1D-435B-9F8E-55032430DB22}"/>
+                <a16:creationId xmlns:a16="http://schemas.microsoft.com/office/drawing/2014/main" id="{7D6FB315-B3EC-48AA-BD04-A013C550A894}"/>
               </a:ext>
             </a:extLst>
           </p:cNvPr>
@@ -10347,7 +10352,7 @@
                 <a:ea typeface="Georgia"/>
                 <a:cs typeface="Georgia"/>
               </a:rPr>
-              <a:t>Продолжение при изменении условий</a:t>
+              <a:t>Встречу перенесли раньше</a:t>
             </a:r>
           </a:p>
         </p:txBody>
@@ -10357,7 +10362,7 @@
           <p:cNvPr id="2" name="">
             <a:extLst xmlns:a="http://schemas.openxmlformats.org/drawingml/2006/main">
               <a:ext uri="{FF2B5EF4-FFF2-40B4-BE49-F238E27FC236}">
-                <a16:creationId xmlns:a16="http://schemas.microsoft.com/office/drawing/2014/main" id="{64A96BCD-E172-4571-B271-228D5C7F0F20}"/>
+                <a16:creationId xmlns:a16="http://schemas.microsoft.com/office/drawing/2014/main" id="{362DB25A-E1BF-4DF7-BF52-F531BB208850}"/>
               </a:ext>
             </a:extLst>
           </p:cNvPr>
@@ -10519,7 +10524,7 @@
           <p:cNvPr id="3" name="">
             <a:extLst xmlns:a="http://schemas.openxmlformats.org/drawingml/2006/main">
               <a:ext uri="{FF2B5EF4-FFF2-40B4-BE49-F238E27FC236}">
-                <a16:creationId xmlns:a16="http://schemas.microsoft.com/office/drawing/2014/main" id="{7ACD0E77-DC7F-442E-8E62-07E8A723DD8F}"/>
+                <a16:creationId xmlns:a16="http://schemas.microsoft.com/office/drawing/2014/main" id="{96EF5DA9-8D41-4930-9D3A-F2FE2A99954B}"/>
               </a:ext>
             </a:extLst>
           </p:cNvPr>
@@ -10529,7 +10534,7 @@
           <p:nvPr/>
         </p:nvPicPr>
         <p:blipFill>
-          <a:blip xmlns:r="http://schemas.openxmlformats.org/officeDocument/2006/relationships" xmlns:a="http://schemas.openxmlformats.org/drawingml/2006/main" r:embed="Rbf158f30aa324d1a"/>
+          <a:blip xmlns:r="http://schemas.openxmlformats.org/officeDocument/2006/relationships" xmlns:a="http://schemas.openxmlformats.org/drawingml/2006/main" r:embed="Rac5a4a8f467c41b4"/>
           <a:srcRect xmlns:a="http://schemas.openxmlformats.org/drawingml/2006/main" l="5000" t="77083" r="51719" b="0"/>
           <a:stretch xmlns:a="http://schemas.openxmlformats.org/drawingml/2006/main"/>
         </p:blipFill>
@@ -10548,7 +10553,7 @@
           <p:cNvPr id="4" name="">
             <a:extLst xmlns:a="http://schemas.openxmlformats.org/drawingml/2006/main">
               <a:ext uri="{FF2B5EF4-FFF2-40B4-BE49-F238E27FC236}">
-                <a16:creationId xmlns:a16="http://schemas.microsoft.com/office/drawing/2014/main" id="{5CDE5A2D-840B-4EE8-91A3-79F994DEB019}"/>
+                <a16:creationId xmlns:a16="http://schemas.microsoft.com/office/drawing/2014/main" id="{550BDA7B-0F00-400A-8714-EB81A8FCC0BB}"/>
               </a:ext>
             </a:extLst>
           </p:cNvPr>
@@ -10764,7 +10769,7 @@
           <p:cNvPr id="5" name="">
             <a:extLst xmlns:a="http://schemas.openxmlformats.org/drawingml/2006/main">
               <a:ext uri="{FF2B5EF4-FFF2-40B4-BE49-F238E27FC236}">
-                <a16:creationId xmlns:a16="http://schemas.microsoft.com/office/drawing/2014/main" id="{E1B521B2-6B85-4FCD-B619-EB388674BE01}"/>
+                <a16:creationId xmlns:a16="http://schemas.microsoft.com/office/drawing/2014/main" id="{B87A6F3A-500C-420F-ABD6-DAAB42F1D024}"/>
               </a:ext>
             </a:extLst>
           </p:cNvPr>
@@ -10924,7 +10929,7 @@
     </p:spTree>
     <p:extLst>
       <p:ext uri="{BB962C8B-B14F-4D97-AF65-F5344CB8AC3E}">
-        <p14:creationId xmlns:p14="http://schemas.microsoft.com/office/powerpoint/2010/main" val="1270628911"/>
+        <p14:creationId xmlns:p14="http://schemas.microsoft.com/office/powerpoint/2010/main" val="929753200"/>
       </p:ext>
     </p:extLst>
   </p:cSld>
@@ -10955,7 +10960,7 @@
           <p:cNvPr id="6" name="">
             <a:extLst xmlns:a="http://schemas.openxmlformats.org/drawingml/2006/main">
               <a:ext uri="{FF2B5EF4-FFF2-40B4-BE49-F238E27FC236}">
-                <a16:creationId xmlns:a16="http://schemas.microsoft.com/office/drawing/2014/main" id="{BF802C88-ECA1-4656-8601-6DDE82FF1C20}"/>
+                <a16:creationId xmlns:a16="http://schemas.microsoft.com/office/drawing/2014/main" id="{7E41DE27-768F-4363-9C0D-1A7FDA7E7652}"/>
               </a:ext>
             </a:extLst>
           </p:cNvPr>
@@ -11117,7 +11122,7 @@
           <p:cNvPr id="2" name="">
             <a:extLst xmlns:a="http://schemas.openxmlformats.org/drawingml/2006/main">
               <a:ext uri="{FF2B5EF4-FFF2-40B4-BE49-F238E27FC236}">
-                <a16:creationId xmlns:a16="http://schemas.microsoft.com/office/drawing/2014/main" id="{DABFA502-F398-44EA-BF11-23171B1A514C}"/>
+                <a16:creationId xmlns:a16="http://schemas.microsoft.com/office/drawing/2014/main" id="{9BAA316A-A36B-4AB3-B486-2B2FDD539544}"/>
               </a:ext>
             </a:extLst>
           </p:cNvPr>
@@ -11127,7 +11132,7 @@
           <p:nvPr/>
         </p:nvPicPr>
         <p:blipFill>
-          <a:blip xmlns:r="http://schemas.openxmlformats.org/officeDocument/2006/relationships" xmlns:a="http://schemas.openxmlformats.org/drawingml/2006/main" r:embed="R525dd576876a460b"/>
+          <a:blip xmlns:r="http://schemas.openxmlformats.org/officeDocument/2006/relationships" xmlns:a="http://schemas.openxmlformats.org/drawingml/2006/main" r:embed="Rfd1aae041aff4eff"/>
           <a:srcRect xmlns:a="http://schemas.openxmlformats.org/drawingml/2006/main" l="17969" t="45833" r="17969" b="0"/>
           <a:stretch xmlns:a="http://schemas.openxmlformats.org/drawingml/2006/main"/>
         </p:blipFill>
@@ -11146,7 +11151,7 @@
           <p:cNvPr id="3" name="">
             <a:extLst xmlns:a="http://schemas.openxmlformats.org/drawingml/2006/main">
               <a:ext uri="{FF2B5EF4-FFF2-40B4-BE49-F238E27FC236}">
-                <a16:creationId xmlns:a16="http://schemas.microsoft.com/office/drawing/2014/main" id="{424F862D-B018-4B64-91F4-1788AA6E78BC}"/>
+                <a16:creationId xmlns:a16="http://schemas.microsoft.com/office/drawing/2014/main" id="{AE87C13D-6B08-4A7B-8C93-4E62AB9E9BB7}"/>
               </a:ext>
             </a:extLst>
           </p:cNvPr>
@@ -11335,7 +11340,7 @@
           <p:cNvPr id="4" name="">
             <a:extLst xmlns:a="http://schemas.openxmlformats.org/drawingml/2006/main">
               <a:ext uri="{FF2B5EF4-FFF2-40B4-BE49-F238E27FC236}">
-                <a16:creationId xmlns:a16="http://schemas.microsoft.com/office/drawing/2014/main" id="{54307C03-4350-4F93-BF4A-91E4C6A95B6F}"/>
+                <a16:creationId xmlns:a16="http://schemas.microsoft.com/office/drawing/2014/main" id="{8C8644EC-4267-47E9-9B5A-8ED8136A3375}"/>
               </a:ext>
             </a:extLst>
           </p:cNvPr>
@@ -11524,7 +11529,7 @@
           <p:cNvPr id="5" name="">
             <a:extLst xmlns:a="http://schemas.openxmlformats.org/drawingml/2006/main">
               <a:ext uri="{FF2B5EF4-FFF2-40B4-BE49-F238E27FC236}">
-                <a16:creationId xmlns:a16="http://schemas.microsoft.com/office/drawing/2014/main" id="{3FB171BD-BB10-4334-BBB2-9ED0AF40FDD7}"/>
+                <a16:creationId xmlns:a16="http://schemas.microsoft.com/office/drawing/2014/main" id="{23C7BC13-5670-450A-A18A-DD120A905638}"/>
               </a:ext>
             </a:extLst>
           </p:cNvPr>
@@ -11711,7 +11716,7 @@
     </p:spTree>
     <p:extLst>
       <p:ext uri="{BB962C8B-B14F-4D97-AF65-F5344CB8AC3E}">
-        <p14:creationId xmlns:p14="http://schemas.microsoft.com/office/powerpoint/2010/main" val="1614051673"/>
+        <p14:creationId xmlns:p14="http://schemas.microsoft.com/office/powerpoint/2010/main" val="618984627"/>
       </p:ext>
     </p:extLst>
   </p:cSld>
@@ -11742,7 +11747,7 @@
           <p:cNvPr id="9" name="">
             <a:extLst xmlns:a="http://schemas.openxmlformats.org/drawingml/2006/main">
               <a:ext uri="{FF2B5EF4-FFF2-40B4-BE49-F238E27FC236}">
-                <a16:creationId xmlns:a16="http://schemas.microsoft.com/office/drawing/2014/main" id="{55DB5598-656C-41A4-AD14-B7DEEE6D7F56}"/>
+                <a16:creationId xmlns:a16="http://schemas.microsoft.com/office/drawing/2014/main" id="{2EE3DD8F-CEE6-43A0-9C43-C3C0AC373EDC}"/>
               </a:ext>
             </a:extLst>
           </p:cNvPr>
@@ -11904,7 +11909,7 @@
           <p:cNvPr id="2" name="">
             <a:extLst xmlns:a="http://schemas.openxmlformats.org/drawingml/2006/main">
               <a:ext uri="{FF2B5EF4-FFF2-40B4-BE49-F238E27FC236}">
-                <a16:creationId xmlns:a16="http://schemas.microsoft.com/office/drawing/2014/main" id="{671F700C-D06C-4E79-A5B3-3A8926757B0F}"/>
+                <a16:creationId xmlns:a16="http://schemas.microsoft.com/office/drawing/2014/main" id="{4C0D3467-E3E2-4C13-9D03-D4E89346BB4F}"/>
               </a:ext>
             </a:extLst>
           </p:cNvPr>
@@ -12066,7 +12071,7 @@
           <p:cNvPr id="3" name="">
             <a:extLst xmlns:a="http://schemas.openxmlformats.org/drawingml/2006/main">
               <a:ext uri="{FF2B5EF4-FFF2-40B4-BE49-F238E27FC236}">
-                <a16:creationId xmlns:a16="http://schemas.microsoft.com/office/drawing/2014/main" id="{FDFA9107-D75D-47E2-83D2-26D1AB174784}"/>
+                <a16:creationId xmlns:a16="http://schemas.microsoft.com/office/drawing/2014/main" id="{04A5F7D4-8846-454C-BADB-21654EAE09E3}"/>
               </a:ext>
             </a:extLst>
           </p:cNvPr>
@@ -12282,7 +12287,7 @@
           <p:cNvPr id="4" name="">
             <a:extLst xmlns:a="http://schemas.openxmlformats.org/drawingml/2006/main">
               <a:ext uri="{FF2B5EF4-FFF2-40B4-BE49-F238E27FC236}">
-                <a16:creationId xmlns:a16="http://schemas.microsoft.com/office/drawing/2014/main" id="{3A705863-CE03-4D33-830E-03482C84ED26}"/>
+                <a16:creationId xmlns:a16="http://schemas.microsoft.com/office/drawing/2014/main" id="{D3CF7145-F51A-4CAD-B2CA-500561362B67}"/>
               </a:ext>
             </a:extLst>
           </p:cNvPr>
@@ -12444,7 +12449,7 @@
           <p:cNvPr id="5" name="">
             <a:extLst xmlns:a="http://schemas.openxmlformats.org/drawingml/2006/main">
               <a:ext uri="{FF2B5EF4-FFF2-40B4-BE49-F238E27FC236}">
-                <a16:creationId xmlns:a16="http://schemas.microsoft.com/office/drawing/2014/main" id="{1DBBA51C-5490-4FB3-BFFD-0207ECA27F9B}"/>
+                <a16:creationId xmlns:a16="http://schemas.microsoft.com/office/drawing/2014/main" id="{C0CB8E42-A937-4805-8EDD-4993E04F10FB}"/>
               </a:ext>
             </a:extLst>
           </p:cNvPr>
@@ -12660,7 +12665,7 @@
           <p:cNvPr id="6" name="">
             <a:extLst xmlns:a="http://schemas.openxmlformats.org/drawingml/2006/main">
               <a:ext uri="{FF2B5EF4-FFF2-40B4-BE49-F238E27FC236}">
-                <a16:creationId xmlns:a16="http://schemas.microsoft.com/office/drawing/2014/main" id="{81C876EB-4512-4630-8735-32F436F65C05}"/>
+                <a16:creationId xmlns:a16="http://schemas.microsoft.com/office/drawing/2014/main" id="{F2AB8034-B72E-4A98-A9D8-7D1B27038D21}"/>
               </a:ext>
             </a:extLst>
           </p:cNvPr>
@@ -12822,7 +12827,7 @@
           <p:cNvPr id="7" name="">
             <a:extLst xmlns:a="http://schemas.openxmlformats.org/drawingml/2006/main">
               <a:ext uri="{FF2B5EF4-FFF2-40B4-BE49-F238E27FC236}">
-                <a16:creationId xmlns:a16="http://schemas.microsoft.com/office/drawing/2014/main" id="{300166B8-D523-4BD7-B572-4C20AF2824E5}"/>
+                <a16:creationId xmlns:a16="http://schemas.microsoft.com/office/drawing/2014/main" id="{84777B74-5EAB-4197-A461-F713879618CF}"/>
               </a:ext>
             </a:extLst>
           </p:cNvPr>
@@ -13038,7 +13043,7 @@
           <p:cNvPr id="8" name="">
             <a:extLst xmlns:a="http://schemas.openxmlformats.org/drawingml/2006/main">
               <a:ext uri="{FF2B5EF4-FFF2-40B4-BE49-F238E27FC236}">
-                <a16:creationId xmlns:a16="http://schemas.microsoft.com/office/drawing/2014/main" id="{09DA4F93-EA4C-4A6E-B86A-003D2A7E9E6F}"/>
+                <a16:creationId xmlns:a16="http://schemas.microsoft.com/office/drawing/2014/main" id="{E5A72100-3C75-4534-910D-66DFB6A92C83}"/>
               </a:ext>
             </a:extLst>
           </p:cNvPr>
@@ -13198,7 +13203,7 @@
     </p:spTree>
     <p:extLst>
       <p:ext uri="{BB962C8B-B14F-4D97-AF65-F5344CB8AC3E}">
-        <p14:creationId xmlns:p14="http://schemas.microsoft.com/office/powerpoint/2010/main" val="786136586"/>
+        <p14:creationId xmlns:p14="http://schemas.microsoft.com/office/powerpoint/2010/main" val="538858854"/>
       </p:ext>
     </p:extLst>
   </p:cSld>
@@ -13229,7 +13234,7 @@
           <p:cNvPr id="8" name="">
             <a:extLst xmlns:a="http://schemas.openxmlformats.org/drawingml/2006/main">
               <a:ext uri="{FF2B5EF4-FFF2-40B4-BE49-F238E27FC236}">
-                <a16:creationId xmlns:a16="http://schemas.microsoft.com/office/drawing/2014/main" id="{1BA34AAF-34E1-4C40-AA3C-E47BC6E677D3}"/>
+                <a16:creationId xmlns:a16="http://schemas.microsoft.com/office/drawing/2014/main" id="{85A9DEC6-F770-47B3-AC24-34CC2DE55D10}"/>
               </a:ext>
             </a:extLst>
           </p:cNvPr>
@@ -13391,7 +13396,7 @@
           <p:cNvPr id="2" name="">
             <a:extLst xmlns:a="http://schemas.openxmlformats.org/drawingml/2006/main">
               <a:ext uri="{FF2B5EF4-FFF2-40B4-BE49-F238E27FC236}">
-                <a16:creationId xmlns:a16="http://schemas.microsoft.com/office/drawing/2014/main" id="{5EB210EE-BD5D-4FC7-877C-4AA0B27CF54B}"/>
+                <a16:creationId xmlns:a16="http://schemas.microsoft.com/office/drawing/2014/main" id="{20D38B11-82A3-45BD-8EA5-56D18B4CC356}"/>
               </a:ext>
             </a:extLst>
           </p:cNvPr>
@@ -13401,7 +13406,7 @@
           <p:nvPr/>
         </p:nvPicPr>
         <p:blipFill>
-          <a:blip xmlns:r="http://schemas.openxmlformats.org/officeDocument/2006/relationships" xmlns:a="http://schemas.openxmlformats.org/drawingml/2006/main" r:embed="Rdc42a1d7aec24147"/>
+          <a:blip xmlns:r="http://schemas.openxmlformats.org/officeDocument/2006/relationships" xmlns:a="http://schemas.openxmlformats.org/drawingml/2006/main" r:embed="R75e87091460d4f2b"/>
           <a:srcRect xmlns:a="http://schemas.openxmlformats.org/drawingml/2006/main" l="25469" t="15000" r="25469" b="9028"/>
           <a:stretch xmlns:a="http://schemas.openxmlformats.org/drawingml/2006/main"/>
         </p:blipFill>
@@ -13420,7 +13425,7 @@
           <p:cNvPr id="3" name="">
             <a:extLst xmlns:a="http://schemas.openxmlformats.org/drawingml/2006/main">
               <a:ext uri="{FF2B5EF4-FFF2-40B4-BE49-F238E27FC236}">
-                <a16:creationId xmlns:a16="http://schemas.microsoft.com/office/drawing/2014/main" id="{B22A6903-5077-4829-BCFF-C198423D43EF}"/>
+                <a16:creationId xmlns:a16="http://schemas.microsoft.com/office/drawing/2014/main" id="{FA33414B-17DA-4F3F-A91E-F45F7D9C96F5}"/>
               </a:ext>
             </a:extLst>
           </p:cNvPr>
@@ -13582,7 +13587,7 @@
           <p:cNvPr id="4" name="">
             <a:extLst xmlns:a="http://schemas.openxmlformats.org/drawingml/2006/main">
               <a:ext uri="{FF2B5EF4-FFF2-40B4-BE49-F238E27FC236}">
-                <a16:creationId xmlns:a16="http://schemas.microsoft.com/office/drawing/2014/main" id="{31B5D23D-9BCF-4201-9E06-52B08434D8DE}"/>
+                <a16:creationId xmlns:a16="http://schemas.microsoft.com/office/drawing/2014/main" id="{BD02EBB1-F00B-4626-9DCC-D2B18DE9B807}"/>
               </a:ext>
             </a:extLst>
           </p:cNvPr>
@@ -13771,7 +13776,7 @@
           <p:cNvPr id="5" name="">
             <a:extLst xmlns:a="http://schemas.openxmlformats.org/drawingml/2006/main">
               <a:ext uri="{FF2B5EF4-FFF2-40B4-BE49-F238E27FC236}">
-                <a16:creationId xmlns:a16="http://schemas.microsoft.com/office/drawing/2014/main" id="{AA93FD55-87F3-4FEE-8174-66B8EE6D48AB}"/>
+                <a16:creationId xmlns:a16="http://schemas.microsoft.com/office/drawing/2014/main" id="{A3D1FCD9-A740-4F72-93D4-3355C843B1BB}"/>
               </a:ext>
             </a:extLst>
           </p:cNvPr>
@@ -13923,7 +13928,7 @@
                 <a:ea typeface="Arial"/>
                 <a:cs typeface="Arial"/>
               </a:rPr>
-              <a:t>259 проверок кода</a:t>
+              <a:t>278 проверок кода</a:t>
             </a:r>
           </a:p>
           <a:p xmlns:a="http://schemas.openxmlformats.org/drawingml/2006/main">
@@ -13960,7 +13965,7 @@
           <p:cNvPr id="6" name="">
             <a:extLst xmlns:a="http://schemas.openxmlformats.org/drawingml/2006/main">
               <a:ext uri="{FF2B5EF4-FFF2-40B4-BE49-F238E27FC236}">
-                <a16:creationId xmlns:a16="http://schemas.microsoft.com/office/drawing/2014/main" id="{65749E98-0EF6-4005-A59E-FF1803E253C7}"/>
+                <a16:creationId xmlns:a16="http://schemas.microsoft.com/office/drawing/2014/main" id="{748E4A43-3A98-4B29-A264-A881EDB65298}"/>
               </a:ext>
             </a:extLst>
           </p:cNvPr>
@@ -14149,7 +14154,7 @@
           <p:cNvPr id="7" name="">
             <a:extLst xmlns:a="http://schemas.openxmlformats.org/drawingml/2006/main">
               <a:ext uri="{FF2B5EF4-FFF2-40B4-BE49-F238E27FC236}">
-                <a16:creationId xmlns:a16="http://schemas.microsoft.com/office/drawing/2014/main" id="{102B4F15-5B62-4B71-8D3D-CB769E0FFA7D}"/>
+                <a16:creationId xmlns:a16="http://schemas.microsoft.com/office/drawing/2014/main" id="{5C3BFA09-58AC-4C36-9150-44D48AB9B14A}"/>
               </a:ext>
             </a:extLst>
           </p:cNvPr>
@@ -14309,7 +14314,7 @@
     </p:spTree>
     <p:extLst>
       <p:ext uri="{BB962C8B-B14F-4D97-AF65-F5344CB8AC3E}">
-        <p14:creationId xmlns:p14="http://schemas.microsoft.com/office/powerpoint/2010/main" val="1034748390"/>
+        <p14:creationId xmlns:p14="http://schemas.microsoft.com/office/powerpoint/2010/main" val="532914486"/>
       </p:ext>
     </p:extLst>
   </p:cSld>
@@ -14340,7 +14345,7 @@
           <p:cNvPr id="7" name="">
             <a:extLst xmlns:a="http://schemas.openxmlformats.org/drawingml/2006/main">
               <a:ext uri="{FF2B5EF4-FFF2-40B4-BE49-F238E27FC236}">
-                <a16:creationId xmlns:a16="http://schemas.microsoft.com/office/drawing/2014/main" id="{156F2DB1-08C7-4D9C-87E7-8F533C90F242}"/>
+                <a16:creationId xmlns:a16="http://schemas.microsoft.com/office/drawing/2014/main" id="{8F7CB017-3137-434C-8AB1-17DF64BDD875}"/>
               </a:ext>
             </a:extLst>
           </p:cNvPr>
@@ -14502,7 +14507,7 @@
           <p:cNvPr id="2" name="">
             <a:extLst xmlns:a="http://schemas.openxmlformats.org/drawingml/2006/main">
               <a:ext uri="{FF2B5EF4-FFF2-40B4-BE49-F238E27FC236}">
-                <a16:creationId xmlns:a16="http://schemas.microsoft.com/office/drawing/2014/main" id="{9597F2E3-1C4E-47F5-AC09-8F20B6901A02}"/>
+                <a16:creationId xmlns:a16="http://schemas.microsoft.com/office/drawing/2014/main" id="{B588CD58-2145-440C-BE48-76E684727479}"/>
               </a:ext>
             </a:extLst>
           </p:cNvPr>
@@ -14691,7 +14696,7 @@
           <p:cNvPr id="3" name="">
             <a:extLst xmlns:a="http://schemas.openxmlformats.org/drawingml/2006/main">
               <a:ext uri="{FF2B5EF4-FFF2-40B4-BE49-F238E27FC236}">
-                <a16:creationId xmlns:a16="http://schemas.microsoft.com/office/drawing/2014/main" id="{0CFFF0E5-BB47-4BF2-9FCA-80E80223EEBF}"/>
+                <a16:creationId xmlns:a16="http://schemas.microsoft.com/office/drawing/2014/main" id="{19399740-E9C0-47EE-9A52-EEC4F268DD93}"/>
               </a:ext>
             </a:extLst>
           </p:cNvPr>
@@ -14880,7 +14885,7 @@
           <p:cNvPr id="4" name="">
             <a:extLst xmlns:a="http://schemas.openxmlformats.org/drawingml/2006/main">
               <a:ext uri="{FF2B5EF4-FFF2-40B4-BE49-F238E27FC236}">
-                <a16:creationId xmlns:a16="http://schemas.microsoft.com/office/drawing/2014/main" id="{40E67373-2F83-453E-B873-ACF7CF6F3615}"/>
+                <a16:creationId xmlns:a16="http://schemas.microsoft.com/office/drawing/2014/main" id="{3BB9225B-5BAA-4137-94E6-28B3BEBA1F9F}"/>
               </a:ext>
             </a:extLst>
           </p:cNvPr>
@@ -15069,7 +15074,7 @@
           <p:cNvPr id="5" name="">
             <a:extLst xmlns:a="http://schemas.openxmlformats.org/drawingml/2006/main">
               <a:ext uri="{FF2B5EF4-FFF2-40B4-BE49-F238E27FC236}">
-                <a16:creationId xmlns:a16="http://schemas.microsoft.com/office/drawing/2014/main" id="{B7D6B607-7E48-4744-B7D6-AD2714DBA9B0}"/>
+                <a16:creationId xmlns:a16="http://schemas.microsoft.com/office/drawing/2014/main" id="{7887EB11-5DFD-4E1A-8C4E-67F753967FD2}"/>
               </a:ext>
             </a:extLst>
           </p:cNvPr>
@@ -15079,7 +15084,7 @@
           <p:nvPr/>
         </p:nvPicPr>
         <p:blipFill>
-          <a:blip xmlns:r="http://schemas.openxmlformats.org/officeDocument/2006/relationships" xmlns:a="http://schemas.openxmlformats.org/drawingml/2006/main" r:embed="Rb78b5ce3d8884b3d"/>
+          <a:blip xmlns:r="http://schemas.openxmlformats.org/officeDocument/2006/relationships" xmlns:a="http://schemas.openxmlformats.org/drawingml/2006/main" r:embed="R108186f38e994d62"/>
           <a:stretch xmlns:a="http://schemas.openxmlformats.org/drawingml/2006/main"/>
         </p:blipFill>
         <p:spPr>
@@ -15097,7 +15102,7 @@
           <p:cNvPr id="6" name="">
             <a:extLst xmlns:a="http://schemas.openxmlformats.org/drawingml/2006/main">
               <a:ext uri="{FF2B5EF4-FFF2-40B4-BE49-F238E27FC236}">
-                <a16:creationId xmlns:a16="http://schemas.microsoft.com/office/drawing/2014/main" id="{A162997F-54CE-4B81-9A42-18DFBCB35308}"/>
+                <a16:creationId xmlns:a16="http://schemas.microsoft.com/office/drawing/2014/main" id="{A8F8F91D-5E39-4D5E-B1DD-706830286F6D}"/>
               </a:ext>
             </a:extLst>
           </p:cNvPr>
@@ -15257,7 +15262,7 @@
     </p:spTree>
     <p:extLst>
       <p:ext uri="{BB962C8B-B14F-4D97-AF65-F5344CB8AC3E}">
-        <p14:creationId xmlns:p14="http://schemas.microsoft.com/office/powerpoint/2010/main" val="336761102"/>
+        <p14:creationId xmlns:p14="http://schemas.microsoft.com/office/powerpoint/2010/main" val="74380151"/>
       </p:ext>
     </p:extLst>
   </p:cSld>

</xml_diff>